<commit_message>
Add composition gate for external markdown evaluation
</commit_message>
<xml_diff>
--- a/artifacts/external-markdown-visual-eval/iteration-01/build/deck.pptx
+++ b/artifacts/external-markdown-visual-eval/iteration-01/build/deck.pptx
@@ -7125,7 +7125,7 @@
                 <a:ea typeface="Pretendard" pitchFamily="34" charset="-122"/>
                 <a:cs typeface="Pretendard" pitchFamily="34" charset="-120"/>
               </a:rPr>
-              <a:t>03. vuejs/core</a:t>
+              <a:t>03. Vue</a:t>
             </a:r>
             <a:endParaRPr lang="en-US" sz="3400" dirty="0"/>
           </a:p>
@@ -7751,7 +7751,7 @@
                 <a:ea typeface="Pretendard" pitchFamily="34" charset="-122"/>
                 <a:cs typeface="Pretendard" pitchFamily="34" charset="-120"/>
               </a:rPr>
-              <a:t>03. vuejs/core (Cont. 2/2)</a:t>
+              <a:t>03. Vue (Cont. 2/2)</a:t>
             </a:r>
             <a:endParaRPr lang="en-US" sz="3400" dirty="0"/>
           </a:p>
@@ -13313,7 +13313,7 @@
                 <a:ea typeface="Pretendard" pitchFamily="34" charset="-122"/>
                 <a:cs typeface="Pretendard" pitchFamily="34" charset="-120"/>
               </a:rPr>
-              <a:t>07  03. vuejs/core</a:t>
+              <a:t>07  03. Vue</a:t>
             </a:r>
             <a:endParaRPr lang="en-US" sz="1800" dirty="0"/>
           </a:p>
@@ -21086,7 +21086,7 @@
                 <a:ea typeface="Pretendard" pitchFamily="34" charset="-122"/>
                 <a:cs typeface="Pretendard" pitchFamily="34" charset="-120"/>
               </a:rPr>
-              <a:t>05  15. if you are updating an existing checkout</a:t>
+              <a:t>05  15. PyTorch</a:t>
             </a:r>
             <a:endParaRPr lang="en-US" sz="1800" dirty="0"/>
           </a:p>
@@ -21254,7 +21254,7 @@
                 <a:ea typeface="Pretendard" pitchFamily="34" charset="-122"/>
                 <a:cs typeface="Pretendard" pitchFamily="34" charset="-120"/>
               </a:rPr>
-              <a:t>09  19. venv</a:t>
+              <a:t>09  19. Transformers</a:t>
             </a:r>
             <a:endParaRPr lang="en-US" sz="1800" dirty="0"/>
           </a:p>
@@ -21380,7 +21380,7 @@
                 <a:ea typeface="Pretendard" pitchFamily="34" charset="-122"/>
                 <a:cs typeface="Pretendard" pitchFamily="34" charset="-120"/>
               </a:rPr>
-              <a:t>12  22. plotly.py</a:t>
+              <a:t>12  22. Plotly.py</a:t>
             </a:r>
             <a:endParaRPr lang="en-US" sz="1800" dirty="0"/>
           </a:p>
@@ -24307,7 +24307,7 @@
                 <a:ea typeface="Pretendard" pitchFamily="34" charset="-122"/>
                 <a:cs typeface="Pretendard" pitchFamily="34" charset="-120"/>
               </a:rPr>
-              <a:t>15. if you are updating an existing checkout</a:t>
+              <a:t>15. PyTorch</a:t>
             </a:r>
             <a:endParaRPr lang="en-US" sz="3400" dirty="0"/>
           </a:p>
@@ -24933,7 +24933,7 @@
                 <a:ea typeface="Pretendard" pitchFamily="34" charset="-122"/>
                 <a:cs typeface="Pretendard" pitchFamily="34" charset="-120"/>
               </a:rPr>
-              <a:t>15. if you are updating an existing checkout (Cont. 2/2)</a:t>
+              <a:t>15. PyTorch (Cont. 2/2)</a:t>
             </a:r>
             <a:endParaRPr lang="en-US" sz="3400" dirty="0"/>
           </a:p>
@@ -30291,7 +30291,7 @@
                 <a:ea typeface="Pretendard" pitchFamily="34" charset="-122"/>
                 <a:cs typeface="Pretendard" pitchFamily="34" charset="-120"/>
               </a:rPr>
-              <a:t>19. venv</a:t>
+              <a:t>19. Transformers</a:t>
             </a:r>
             <a:endParaRPr lang="en-US" sz="3400" dirty="0"/>
           </a:p>
@@ -30917,7 +30917,7 @@
                 <a:ea typeface="Pretendard" pitchFamily="34" charset="-122"/>
                 <a:cs typeface="Pretendard" pitchFamily="34" charset="-120"/>
               </a:rPr>
-              <a:t>19. venv (Cont. 2/2)</a:t>
+              <a:t>19. Transformers (Cont. 2/2)</a:t>
             </a:r>
             <a:endParaRPr lang="en-US" sz="3400" dirty="0"/>
           </a:p>
@@ -33804,7 +33804,7 @@
                 <a:ea typeface="Pretendard" pitchFamily="34" charset="-122"/>
                 <a:cs typeface="Pretendard" pitchFamily="34" charset="-120"/>
               </a:rPr>
-              <a:t>22. plotly.py</a:t>
+              <a:t>22. Plotly.py</a:t>
             </a:r>
             <a:endParaRPr lang="en-US" sz="3400" dirty="0"/>
           </a:p>

</xml_diff>